<commit_message>
System Design 101 (vi): sd-11-043 successful-result availability definition; simulation models CP write refusals with current reads
Co-Authored-By: Claude Sonnet 5.5 <noreply@anthropic.com>
Claude-Session: https://claude.ai/code/session_01MF1cUkoXgxEMeDan8VPPYR
</commit_message>
<xml_diff>
--- a/system-design-101/vi/lessons/sd-11-043/slides/sd-11-043.pptx
+++ b/system-design-101/vi/lessons/sd-11-043/slides/sd-11-043.pptx
@@ -4336,7 +4336,7 @@
               <a:t> chối ba</a:t>
             </a:r>
             <a:r>
-              <a:rPr lang="en-US" sz="3900" b="1" dirty="0" spc="14" kern="0">
+              <a:rPr lang="en-US" sz="3900" b="1" dirty="0" spc="-6" kern="0">
                 <a:solidFill>
                   <a:srgbClr val="14161C"/>
                 </a:solidFill>
@@ -4344,10 +4344,10 @@
                 <a:ea typeface="Be Vietnam Pro" pitchFamily="34" charset="-122"/>
                 <a:cs typeface="Be Vietnam Pro" pitchFamily="34" charset="-120"/>
               </a:rPr>
-              <a:t> lượt</a:t>
-            </a:r>
-            <a:r>
-              <a:rPr lang="en-US" sz="3900" b="1" dirty="0" spc="3" kern="0">
+              <a:t> lần</a:t>
+            </a:r>
+            <a:r>
+              <a:rPr lang="en-US" sz="3900" b="1" dirty="0" spc="-2" kern="0">
                 <a:solidFill>
                   <a:srgbClr val="14161C"/>
                 </a:solidFill>
@@ -4355,7 +4355,40 @@
                 <a:ea typeface="Be Vietnam Pro" pitchFamily="34" charset="-122"/>
                 <a:cs typeface="Be Vietnam Pro" pitchFamily="34" charset="-120"/>
               </a:rPr>
-              <a:t> đọc.</a:t>
+              <a:t> ghi,</a:t>
+            </a:r>
+            <a:r>
+              <a:rPr lang="en-US" sz="3900" b="1" dirty="0" spc="5" kern="0">
+                <a:solidFill>
+                  <a:srgbClr val="14161C"/>
+                </a:solidFill>
+                <a:latin typeface="Be Vietnam Pro" pitchFamily="34" charset="0"/>
+                <a:ea typeface="Be Vietnam Pro" pitchFamily="34" charset="-122"/>
+                <a:cs typeface="Be Vietnam Pro" pitchFamily="34" charset="-120"/>
+              </a:rPr>
+              <a:t> đọc</a:t>
+            </a:r>
+            <a:r>
+              <a:rPr lang="en-US" sz="3900" b="1" dirty="0" spc="10" kern="0">
+                <a:solidFill>
+                  <a:srgbClr val="14161C"/>
+                </a:solidFill>
+                <a:latin typeface="Be Vietnam Pro" pitchFamily="34" charset="0"/>
+                <a:ea typeface="Be Vietnam Pro" pitchFamily="34" charset="-122"/>
+                <a:cs typeface="Be Vietnam Pro" pitchFamily="34" charset="-120"/>
+              </a:rPr>
+              <a:t> đều</a:t>
+            </a:r>
+            <a:r>
+              <a:rPr lang="en-US" sz="3900" b="1" dirty="0" spc="-8" kern="0">
+                <a:solidFill>
+                  <a:srgbClr val="14161C"/>
+                </a:solidFill>
+                <a:latin typeface="Be Vietnam Pro" pitchFamily="34" charset="0"/>
+                <a:ea typeface="Be Vietnam Pro" pitchFamily="34" charset="-122"/>
+                <a:cs typeface="Be Vietnam Pro" pitchFamily="34" charset="-120"/>
+              </a:rPr>
+              <a:t> đúng.</a:t>
             </a:r>
             <a:endParaRPr lang="en-US" sz="3900" dirty="0"/>
           </a:p>
@@ -4480,15 +4513,26 @@
               <a:buNone/>
             </a:pPr>
             <a:r>
-              <a:rPr lang="en-US" sz="3900" b="1" dirty="0" spc="-97" kern="0">
-                <a:solidFill>
-                  <a:srgbClr val="F3EEE3"/>
-                </a:solidFill>
-                <a:latin typeface="Be Vietnam Pro" pitchFamily="34" charset="0"/>
-                <a:ea typeface="Be Vietnam Pro" pitchFamily="34" charset="-122"/>
-                <a:cs typeface="Be Vietnam Pro" pitchFamily="34" charset="-120"/>
-              </a:rPr>
-              <a:t>Trả</a:t>
+              <a:rPr lang="en-US" sz="3900" b="1" dirty="0" spc="-7" kern="0">
+                <a:solidFill>
+                  <a:srgbClr val="F3EEE3"/>
+                </a:solidFill>
+                <a:latin typeface="Be Vietnam Pro" pitchFamily="34" charset="0"/>
+                <a:ea typeface="Be Vietnam Pro" pitchFamily="34" charset="-122"/>
+                <a:cs typeface="Be Vietnam Pro" pitchFamily="34" charset="-120"/>
+              </a:rPr>
+              <a:t>Nhận</a:t>
+            </a:r>
+            <a:r>
+              <a:rPr lang="en-US" sz="3900" b="1" dirty="0" spc="15" kern="0">
+                <a:solidFill>
+                  <a:srgbClr val="F3EEE3"/>
+                </a:solidFill>
+                <a:latin typeface="Be Vietnam Pro" pitchFamily="34" charset="0"/>
+                <a:ea typeface="Be Vietnam Pro" pitchFamily="34" charset="-122"/>
+                <a:cs typeface="Be Vietnam Pro" pitchFamily="34" charset="-120"/>
+              </a:rPr>
+              <a:t> lượt</a:t>
             </a:r>
             <a:r>
               <a:rPr lang="en-US" sz="3900" b="1" dirty="0" spc="-2" kern="0">
@@ -4499,6 +4543,61 @@
                 <a:ea typeface="Be Vietnam Pro" pitchFamily="34" charset="-122"/>
                 <a:cs typeface="Be Vietnam Pro" pitchFamily="34" charset="-120"/>
               </a:rPr>
+              <a:t> ghi,</a:t>
+            </a:r>
+            <a:r>
+              <a:rPr lang="en-US" sz="3900" b="1" dirty="0" spc="-4" kern="0">
+                <a:solidFill>
+                  <a:srgbClr val="F3EEE3"/>
+                </a:solidFill>
+                <a:latin typeface="Be Vietnam Pro" pitchFamily="34" charset="0"/>
+                <a:ea typeface="Be Vietnam Pro" pitchFamily="34" charset="-122"/>
+                <a:cs typeface="Be Vietnam Pro" pitchFamily="34" charset="-120"/>
+              </a:rPr>
+              <a:t> ba</a:t>
+            </a:r>
+            <a:r>
+              <a:rPr lang="en-US" sz="3900" b="1" dirty="0" spc="15" kern="0">
+                <a:solidFill>
+                  <a:srgbClr val="F3EEE3"/>
+                </a:solidFill>
+                <a:latin typeface="Be Vietnam Pro" pitchFamily="34" charset="0"/>
+                <a:ea typeface="Be Vietnam Pro" pitchFamily="34" charset="-122"/>
+                <a:cs typeface="Be Vietnam Pro" pitchFamily="34" charset="-120"/>
+              </a:rPr>
+              <a:t> lượt</a:t>
+            </a:r>
+            <a:r>
+              <a:rPr lang="en-US" sz="3900" b="1" dirty="0" spc="5" kern="0">
+                <a:solidFill>
+                  <a:srgbClr val="F3EEE3"/>
+                </a:solidFill>
+                <a:latin typeface="Be Vietnam Pro" pitchFamily="34" charset="0"/>
+                <a:ea typeface="Be Vietnam Pro" pitchFamily="34" charset="-122"/>
+                <a:cs typeface="Be Vietnam Pro" pitchFamily="34" charset="-120"/>
+              </a:rPr>
+              <a:t> đọc</a:t>
+            </a:r>
+            <a:r>
+              <a:rPr lang="en-US" sz="3900" b="1" dirty="0" spc="-25" kern="0">
+                <a:solidFill>
+                  <a:srgbClr val="F3EEE3"/>
+                </a:solidFill>
+                <a:latin typeface="Be Vietnam Pro" pitchFamily="34" charset="0"/>
+                <a:ea typeface="Be Vietnam Pro" pitchFamily="34" charset="-122"/>
+                <a:cs typeface="Be Vietnam Pro" pitchFamily="34" charset="-120"/>
+              </a:rPr>
+              <a:t> trả</a:t>
+            </a:r>
+            <a:r>
+              <a:rPr lang="en-US" sz="3900" b="1" dirty="0" spc="-1" kern="0">
+                <a:solidFill>
+                  <a:srgbClr val="F3EEE3"/>
+                </a:solidFill>
+                <a:latin typeface="Be Vietnam Pro" pitchFamily="34" charset="0"/>
+                <a:ea typeface="Be Vietnam Pro" pitchFamily="34" charset="-122"/>
+                <a:cs typeface="Be Vietnam Pro" pitchFamily="34" charset="-120"/>
+              </a:rPr>
               <a:t> giá</a:t>
             </a:r>
             <a:r>
@@ -4513,65 +4612,15 @@
               <a:t> trị</a:t>
             </a:r>
             <a:r>
-              <a:rPr lang="en-US" sz="3900" b="1" dirty="0" spc="-1" kern="0">
-                <a:solidFill>
-                  <a:srgbClr val="F3EEE3"/>
-                </a:solidFill>
-                <a:latin typeface="Be Vietnam Pro" pitchFamily="34" charset="0"/>
-                <a:ea typeface="Be Vietnam Pro" pitchFamily="34" charset="-122"/>
-                <a:cs typeface="Be Vietnam Pro" pitchFamily="34" charset="-120"/>
-              </a:rPr>
-              <a:t> cũ</a:t>
-            </a:r>
-            <a:r>
-              <a:rPr lang="en-US" sz="3900" b="1" dirty="0" spc="-5" kern="0">
-                <a:solidFill>
-                  <a:srgbClr val="F3EEE3"/>
-                </a:solidFill>
-                <a:latin typeface="Be Vietnam Pro" pitchFamily="34" charset="0"/>
-                <a:ea typeface="Be Vietnam Pro" pitchFamily="34" charset="-122"/>
-                <a:cs typeface="Be Vietnam Pro" pitchFamily="34" charset="-120"/>
-              </a:rPr>
-              <a:t> ba</a:t>
-            </a:r>
-            <a:r>
-              <a:rPr lang="en-US" sz="3900" b="1" dirty="0" spc="12" kern="0">
-                <a:solidFill>
-                  <a:srgbClr val="F3EEE3"/>
-                </a:solidFill>
-                <a:latin typeface="Be Vietnam Pro" pitchFamily="34" charset="0"/>
-                <a:ea typeface="Be Vietnam Pro" pitchFamily="34" charset="-122"/>
-                <a:cs typeface="Be Vietnam Pro" pitchFamily="34" charset="-120"/>
-              </a:rPr>
-              <a:t> lượt,</a:t>
-            </a:r>
-            <a:endParaRPr lang="en-US" sz="3900" dirty="0"/>
-          </a:p>
-          <a:p>
-            <a:pPr algn="l" indent="0" marL="0">
-              <a:buNone/>
-            </a:pPr>
-            <a:r>
-              <a:rPr lang="en-US" sz="3900" b="1" dirty="0" spc="-27" kern="0">
-                <a:solidFill>
-                  <a:srgbClr val="F3EEE3"/>
-                </a:solidFill>
-                <a:latin typeface="Be Vietnam Pro" pitchFamily="34" charset="0"/>
-                <a:ea typeface="Be Vietnam Pro" pitchFamily="34" charset="-122"/>
-                <a:cs typeface="Be Vietnam Pro" pitchFamily="34" charset="-120"/>
-              </a:rPr>
-              <a:t>rồi</a:t>
-            </a:r>
-            <a:r>
-              <a:rPr lang="en-US" sz="3900" b="1" dirty="0" spc="-5" kern="0">
-                <a:solidFill>
-                  <a:srgbClr val="F3EEE3"/>
-                </a:solidFill>
-                <a:latin typeface="Be Vietnam Pro" pitchFamily="34" charset="0"/>
-                <a:ea typeface="Be Vietnam Pro" pitchFamily="34" charset="-122"/>
-                <a:cs typeface="Be Vietnam Pro" pitchFamily="34" charset="-120"/>
-              </a:rPr>
-              <a:t> hội tụ.</a:t>
+              <a:rPr lang="en-US" sz="3900" b="1" dirty="0" spc="-3" kern="0">
+                <a:solidFill>
+                  <a:srgbClr val="F3EEE3"/>
+                </a:solidFill>
+                <a:latin typeface="Be Vietnam Pro" pitchFamily="34" charset="0"/>
+                <a:ea typeface="Be Vietnam Pro" pitchFamily="34" charset="-122"/>
+                <a:cs typeface="Be Vietnam Pro" pitchFamily="34" charset="-120"/>
+              </a:rPr>
+              <a:t> cũ.</a:t>
             </a:r>
             <a:endParaRPr lang="en-US" sz="3900" dirty="0"/>
           </a:p>
@@ -5639,7 +5688,29 @@
                 <a:ea typeface="Be Vietnam Pro" pitchFamily="34" charset="-122"/>
                 <a:cs typeface="Be Vietnam Pro" pitchFamily="34" charset="-120"/>
               </a:rPr>
-              <a:t> lời.</a:t>
+              <a:t> lời</a:t>
+            </a:r>
+            <a:r>
+              <a:rPr lang="en-US" sz="2100" dirty="0" spc="-2" kern="0">
+                <a:solidFill>
+                  <a:srgbClr val="14161C"/>
+                </a:solidFill>
+                <a:latin typeface="Be Vietnam Pro" pitchFamily="34" charset="0"/>
+                <a:ea typeface="Be Vietnam Pro" pitchFamily="34" charset="-122"/>
+                <a:cs typeface="Be Vietnam Pro" pitchFamily="34" charset="-120"/>
+              </a:rPr>
+              <a:t> thành</a:t>
+            </a:r>
+            <a:r>
+              <a:rPr lang="en-US" sz="2100" dirty="0" spc="-1" kern="0">
+                <a:solidFill>
+                  <a:srgbClr val="14161C"/>
+                </a:solidFill>
+                <a:latin typeface="Be Vietnam Pro" pitchFamily="34" charset="0"/>
+                <a:ea typeface="Be Vietnam Pro" pitchFamily="34" charset="-122"/>
+                <a:cs typeface="Be Vietnam Pro" pitchFamily="34" charset="-120"/>
+              </a:rPr>
+              <a:t> công.</a:t>
             </a:r>
             <a:endParaRPr lang="en-US" sz="2100" dirty="0"/>
           </a:p>

</xml_diff>